<commit_message>
update met composer gotcha
</commit_message>
<xml_diff>
--- a/week1 - Laravel Intro/M8Prog laravel 01 - Kickoff.pptx
+++ b/week1 - Laravel Intro/M8Prog laravel 01 - Kickoff.pptx
@@ -9,16 +9,17 @@
     <p:sldId id="258" r:id="rId3"/>
     <p:sldId id="257" r:id="rId4"/>
     <p:sldId id="264" r:id="rId5"/>
-    <p:sldId id="265" r:id="rId6"/>
-    <p:sldId id="267" r:id="rId7"/>
-    <p:sldId id="268" r:id="rId8"/>
-    <p:sldId id="269" r:id="rId9"/>
-    <p:sldId id="272" r:id="rId10"/>
-    <p:sldId id="273" r:id="rId11"/>
-    <p:sldId id="275" r:id="rId12"/>
-    <p:sldId id="274" r:id="rId13"/>
-    <p:sldId id="276" r:id="rId14"/>
-    <p:sldId id="277" r:id="rId15"/>
+    <p:sldId id="278" r:id="rId6"/>
+    <p:sldId id="265" r:id="rId7"/>
+    <p:sldId id="267" r:id="rId8"/>
+    <p:sldId id="268" r:id="rId9"/>
+    <p:sldId id="269" r:id="rId10"/>
+    <p:sldId id="272" r:id="rId11"/>
+    <p:sldId id="273" r:id="rId12"/>
+    <p:sldId id="275" r:id="rId13"/>
+    <p:sldId id="274" r:id="rId14"/>
+    <p:sldId id="276" r:id="rId15"/>
+    <p:sldId id="277" r:id="rId16"/>
   </p:sldIdLst>
   <p:sldSz cx="12192000" cy="6858000"/>
   <p:notesSz cx="6858000" cy="9144000"/>
@@ -128,7 +129,7 @@
 <file path=ppt/revisionInfo.xml><?xml version="1.0" encoding="utf-8"?>
 <p1510:revInfo xmlns:a="http://schemas.openxmlformats.org/drawingml/2006/main" xmlns:r="http://schemas.openxmlformats.org/officeDocument/2006/relationships" xmlns:p1510="http://schemas.microsoft.com/office/powerpoint/2015/10/main">
   <p1510:revLst>
-    <p1510:client id="{8480E6ED-9360-4FC2-B127-D918C1499FC1}" v="2" dt="2026-05-07T09:58:14.726"/>
+    <p1510:client id="{8480E6ED-9360-4FC2-B127-D918C1499FC1}" v="3" dt="2026-05-11T06:16:23.814"/>
   </p1510:revLst>
 </p1510:revInfo>
 </file>
@@ -138,7 +139,7 @@
   <pc:docChgLst>
     <pc:chgData name="Dragan Javorac" userId="913c2858-fb97-4c6e-a42c-b1f1a16b225e" providerId="ADAL" clId="{BC00D9DF-F858-4149-8B7B-F211D448CEDA}"/>
     <pc:docChg chg="undo custSel addSld delSld modSld sldOrd">
-      <pc:chgData name="Dragan Javorac" userId="913c2858-fb97-4c6e-a42c-b1f1a16b225e" providerId="ADAL" clId="{BC00D9DF-F858-4149-8B7B-F211D448CEDA}" dt="2026-05-07T09:58:55.926" v="1452" actId="14100"/>
+      <pc:chgData name="Dragan Javorac" userId="913c2858-fb97-4c6e-a42c-b1f1a16b225e" providerId="ADAL" clId="{BC00D9DF-F858-4149-8B7B-F211D448CEDA}" dt="2026-05-11T06:53:18.717" v="1669" actId="14100"/>
       <pc:docMkLst>
         <pc:docMk/>
       </pc:docMkLst>
@@ -172,12 +173,20 @@
           </ac:spMkLst>
         </pc:spChg>
       </pc:sldChg>
-      <pc:sldChg chg="add">
-        <pc:chgData name="Dragan Javorac" userId="913c2858-fb97-4c6e-a42c-b1f1a16b225e" providerId="ADAL" clId="{BC00D9DF-F858-4149-8B7B-F211D448CEDA}" dt="2026-04-20T13:58:14.417" v="1312"/>
+      <pc:sldChg chg="modSp add mod">
+        <pc:chgData name="Dragan Javorac" userId="913c2858-fb97-4c6e-a42c-b1f1a16b225e" providerId="ADAL" clId="{BC00D9DF-F858-4149-8B7B-F211D448CEDA}" dt="2026-05-11T06:16:20.687" v="1464" actId="20577"/>
         <pc:sldMkLst>
           <pc:docMk/>
           <pc:sldMk cId="4216161161" sldId="264"/>
         </pc:sldMkLst>
+        <pc:spChg chg="mod">
+          <ac:chgData name="Dragan Javorac" userId="913c2858-fb97-4c6e-a42c-b1f1a16b225e" providerId="ADAL" clId="{BC00D9DF-F858-4149-8B7B-F211D448CEDA}" dt="2026-05-11T06:16:20.687" v="1464" actId="20577"/>
+          <ac:spMkLst>
+            <pc:docMk/>
+            <pc:sldMk cId="4216161161" sldId="264"/>
+            <ac:spMk id="3" creationId="{0A78FE0D-D5EE-A73A-3D04-F5666CB44FB6}"/>
+          </ac:spMkLst>
+        </pc:spChg>
       </pc:sldChg>
       <pc:sldChg chg="modSp mod">
         <pc:chgData name="Dragan Javorac" userId="913c2858-fb97-4c6e-a42c-b1f1a16b225e" providerId="ADAL" clId="{BC00D9DF-F858-4149-8B7B-F211D448CEDA}" dt="2026-04-20T12:57:07.869" v="347" actId="20577"/>
@@ -262,13 +271,6 @@
             <ac:picMk id="5" creationId="{BAC3E76A-0EA3-5951-5885-632F43C5F7DE}"/>
           </ac:picMkLst>
         </pc:picChg>
-      </pc:sldChg>
-      <pc:sldChg chg="add del">
-        <pc:chgData name="Dragan Javorac" userId="913c2858-fb97-4c6e-a42c-b1f1a16b225e" providerId="ADAL" clId="{BC00D9DF-F858-4149-8B7B-F211D448CEDA}" dt="2026-05-07T09:56:50.655" v="1444" actId="47"/>
-        <pc:sldMkLst>
-          <pc:docMk/>
-          <pc:sldMk cId="2729798725" sldId="271"/>
-        </pc:sldMkLst>
       </pc:sldChg>
       <pc:sldChg chg="modSp add mod">
         <pc:chgData name="Dragan Javorac" userId="913c2858-fb97-4c6e-a42c-b1f1a16b225e" providerId="ADAL" clId="{BC00D9DF-F858-4149-8B7B-F211D448CEDA}" dt="2026-04-20T13:07:51.355" v="1065" actId="20577"/>
@@ -471,12 +473,35 @@
             <ac:picMk id="5" creationId="{2B35C14B-EE40-E53C-DCF2-153E05F710B9}"/>
           </ac:picMkLst>
         </pc:picChg>
-        <pc:picChg chg="add del mod">
-          <ac:chgData name="Dragan Javorac" userId="913c2858-fb97-4c6e-a42c-b1f1a16b225e" providerId="ADAL" clId="{BC00D9DF-F858-4149-8B7B-F211D448CEDA}" dt="2026-05-07T09:58:52.250" v="1449" actId="478"/>
+      </pc:sldChg>
+      <pc:sldChg chg="delSp modSp add mod">
+        <pc:chgData name="Dragan Javorac" userId="913c2858-fb97-4c6e-a42c-b1f1a16b225e" providerId="ADAL" clId="{BC00D9DF-F858-4149-8B7B-F211D448CEDA}" dt="2026-05-11T06:53:18.717" v="1669" actId="14100"/>
+        <pc:sldMkLst>
+          <pc:docMk/>
+          <pc:sldMk cId="3784629920" sldId="278"/>
+        </pc:sldMkLst>
+        <pc:spChg chg="mod">
+          <ac:chgData name="Dragan Javorac" userId="913c2858-fb97-4c6e-a42c-b1f1a16b225e" providerId="ADAL" clId="{BC00D9DF-F858-4149-8B7B-F211D448CEDA}" dt="2026-05-11T06:16:33.362" v="1492" actId="20577"/>
+          <ac:spMkLst>
+            <pc:docMk/>
+            <pc:sldMk cId="3784629920" sldId="278"/>
+            <ac:spMk id="2" creationId="{40A7B55D-529C-13A7-E740-2FAB3FEE61DC}"/>
+          </ac:spMkLst>
+        </pc:spChg>
+        <pc:spChg chg="mod">
+          <ac:chgData name="Dragan Javorac" userId="913c2858-fb97-4c6e-a42c-b1f1a16b225e" providerId="ADAL" clId="{BC00D9DF-F858-4149-8B7B-F211D448CEDA}" dt="2026-05-11T06:53:18.717" v="1669" actId="14100"/>
+          <ac:spMkLst>
+            <pc:docMk/>
+            <pc:sldMk cId="3784629920" sldId="278"/>
+            <ac:spMk id="3" creationId="{D05685E2-71C0-EBAF-231E-B159B81562D5}"/>
+          </ac:spMkLst>
+        </pc:spChg>
+        <pc:picChg chg="del">
+          <ac:chgData name="Dragan Javorac" userId="913c2858-fb97-4c6e-a42c-b1f1a16b225e" providerId="ADAL" clId="{BC00D9DF-F858-4149-8B7B-F211D448CEDA}" dt="2026-05-11T06:16:39.781" v="1493" actId="478"/>
           <ac:picMkLst>
             <pc:docMk/>
-            <pc:sldMk cId="1039330640" sldId="277"/>
-            <ac:picMk id="7" creationId="{4D8ECB68-BDA5-DC99-0458-1255A5FC22FA}"/>
+            <pc:sldMk cId="3784629920" sldId="278"/>
+            <ac:picMk id="5" creationId="{101ABD39-E080-102A-E372-9215E30EC279}"/>
           </ac:picMkLst>
         </pc:picChg>
       </pc:sldChg>
@@ -634,7 +659,7 @@
           <a:p>
             <a:fld id="{AD36792F-A28E-4983-A7F5-F40ED51D6004}" type="datetimeFigureOut">
               <a:rPr lang="nl-NL" smtClean="0"/>
-              <a:t>7-5-2026</a:t>
+              <a:t>11-5-2026</a:t>
             </a:fld>
             <a:endParaRPr lang="nl-NL"/>
           </a:p>
@@ -834,7 +859,7 @@
           <a:p>
             <a:fld id="{AD36792F-A28E-4983-A7F5-F40ED51D6004}" type="datetimeFigureOut">
               <a:rPr lang="nl-NL" smtClean="0"/>
-              <a:t>7-5-2026</a:t>
+              <a:t>11-5-2026</a:t>
             </a:fld>
             <a:endParaRPr lang="nl-NL"/>
           </a:p>
@@ -1044,7 +1069,7 @@
           <a:p>
             <a:fld id="{AD36792F-A28E-4983-A7F5-F40ED51D6004}" type="datetimeFigureOut">
               <a:rPr lang="nl-NL" smtClean="0"/>
-              <a:t>7-5-2026</a:t>
+              <a:t>11-5-2026</a:t>
             </a:fld>
             <a:endParaRPr lang="nl-NL"/>
           </a:p>
@@ -1244,7 +1269,7 @@
           <a:p>
             <a:fld id="{AD36792F-A28E-4983-A7F5-F40ED51D6004}" type="datetimeFigureOut">
               <a:rPr lang="nl-NL" smtClean="0"/>
-              <a:t>7-5-2026</a:t>
+              <a:t>11-5-2026</a:t>
             </a:fld>
             <a:endParaRPr lang="nl-NL"/>
           </a:p>
@@ -1520,7 +1545,7 @@
           <a:p>
             <a:fld id="{AD36792F-A28E-4983-A7F5-F40ED51D6004}" type="datetimeFigureOut">
               <a:rPr lang="nl-NL" smtClean="0"/>
-              <a:t>7-5-2026</a:t>
+              <a:t>11-5-2026</a:t>
             </a:fld>
             <a:endParaRPr lang="nl-NL"/>
           </a:p>
@@ -1788,7 +1813,7 @@
           <a:p>
             <a:fld id="{AD36792F-A28E-4983-A7F5-F40ED51D6004}" type="datetimeFigureOut">
               <a:rPr lang="nl-NL" smtClean="0"/>
-              <a:t>7-5-2026</a:t>
+              <a:t>11-5-2026</a:t>
             </a:fld>
             <a:endParaRPr lang="nl-NL"/>
           </a:p>
@@ -2203,7 +2228,7 @@
           <a:p>
             <a:fld id="{AD36792F-A28E-4983-A7F5-F40ED51D6004}" type="datetimeFigureOut">
               <a:rPr lang="nl-NL" smtClean="0"/>
-              <a:t>7-5-2026</a:t>
+              <a:t>11-5-2026</a:t>
             </a:fld>
             <a:endParaRPr lang="nl-NL"/>
           </a:p>
@@ -2345,7 +2370,7 @@
           <a:p>
             <a:fld id="{AD36792F-A28E-4983-A7F5-F40ED51D6004}" type="datetimeFigureOut">
               <a:rPr lang="nl-NL" smtClean="0"/>
-              <a:t>7-5-2026</a:t>
+              <a:t>11-5-2026</a:t>
             </a:fld>
             <a:endParaRPr lang="nl-NL"/>
           </a:p>
@@ -2458,7 +2483,7 @@
           <a:p>
             <a:fld id="{AD36792F-A28E-4983-A7F5-F40ED51D6004}" type="datetimeFigureOut">
               <a:rPr lang="nl-NL" smtClean="0"/>
-              <a:t>7-5-2026</a:t>
+              <a:t>11-5-2026</a:t>
             </a:fld>
             <a:endParaRPr lang="nl-NL"/>
           </a:p>
@@ -2771,7 +2796,7 @@
           <a:p>
             <a:fld id="{AD36792F-A28E-4983-A7F5-F40ED51D6004}" type="datetimeFigureOut">
               <a:rPr lang="nl-NL" smtClean="0"/>
-              <a:t>7-5-2026</a:t>
+              <a:t>11-5-2026</a:t>
             </a:fld>
             <a:endParaRPr lang="nl-NL"/>
           </a:p>
@@ -3060,7 +3085,7 @@
           <a:p>
             <a:fld id="{AD36792F-A28E-4983-A7F5-F40ED51D6004}" type="datetimeFigureOut">
               <a:rPr lang="nl-NL" smtClean="0"/>
-              <a:t>7-5-2026</a:t>
+              <a:t>11-5-2026</a:t>
             </a:fld>
             <a:endParaRPr lang="nl-NL"/>
           </a:p>
@@ -3310,7 +3335,7 @@
           <a:p>
             <a:fld id="{AD36792F-A28E-4983-A7F5-F40ED51D6004}" type="datetimeFigureOut">
               <a:rPr lang="nl-NL" smtClean="0"/>
-              <a:t>7-5-2026</a:t>
+              <a:t>11-5-2026</a:t>
             </a:fld>
             <a:endParaRPr lang="nl-NL"/>
           </a:p>
@@ -3836,6 +3861,170 @@
         <p:cNvPr id="1" name="">
           <a:extLst>
             <a:ext uri="{FF2B5EF4-FFF2-40B4-BE49-F238E27FC236}">
+              <a16:creationId xmlns:a16="http://schemas.microsoft.com/office/drawing/2014/main" id="{2EAACB33-43BE-EDF1-1A9E-034E28C6C768}"/>
+            </a:ext>
+          </a:extLst>
+        </p:cNvPr>
+        <p:cNvGrpSpPr/>
+        <p:nvPr/>
+      </p:nvGrpSpPr>
+      <p:grpSpPr>
+        <a:xfrm>
+          <a:off x="0" y="0"/>
+          <a:ext cx="0" cy="0"/>
+          <a:chOff x="0" y="0"/>
+          <a:chExt cx="0" cy="0"/>
+        </a:xfrm>
+      </p:grpSpPr>
+      <p:sp>
+        <p:nvSpPr>
+          <p:cNvPr id="2" name="Title 1">
+            <a:extLst>
+              <a:ext uri="{FF2B5EF4-FFF2-40B4-BE49-F238E27FC236}">
+                <a16:creationId xmlns:a16="http://schemas.microsoft.com/office/drawing/2014/main" id="{79ACB165-A2D9-F103-EA6F-93584CC5166C}"/>
+              </a:ext>
+            </a:extLst>
+          </p:cNvPr>
+          <p:cNvSpPr>
+            <a:spLocks noGrp="1"/>
+          </p:cNvSpPr>
+          <p:nvPr>
+            <p:ph type="title"/>
+          </p:nvPr>
+        </p:nvSpPr>
+        <p:spPr/>
+        <p:txBody>
+          <a:bodyPr/>
+          <a:lstStyle/>
+          <a:p>
+            <a:r>
+              <a:rPr lang="nl-NL" dirty="0"/>
+              <a:t>@@@@@@</a:t>
+            </a:r>
+          </a:p>
+        </p:txBody>
+      </p:sp>
+      <p:sp>
+        <p:nvSpPr>
+          <p:cNvPr id="3" name="Content Placeholder 2">
+            <a:extLst>
+              <a:ext uri="{FF2B5EF4-FFF2-40B4-BE49-F238E27FC236}">
+                <a16:creationId xmlns:a16="http://schemas.microsoft.com/office/drawing/2014/main" id="{18E7F1CB-60BD-BCA2-61ED-D714D805A39C}"/>
+              </a:ext>
+            </a:extLst>
+          </p:cNvPr>
+          <p:cNvSpPr>
+            <a:spLocks noGrp="1"/>
+          </p:cNvSpPr>
+          <p:nvPr>
+            <p:ph idx="1"/>
+          </p:nvPr>
+        </p:nvSpPr>
+        <p:spPr/>
+        <p:txBody>
+          <a:bodyPr>
+            <a:normAutofit/>
+          </a:bodyPr>
+          <a:lstStyle/>
+          <a:p>
+            <a:r>
+              <a:rPr lang="nl-NL" dirty="0"/>
+              <a:t>In de </a:t>
+            </a:r>
+            <a:r>
+              <a:rPr lang="nl-NL" dirty="0" err="1"/>
+              <a:t>blade</a:t>
+            </a:r>
+            <a:r>
+              <a:rPr lang="nl-NL" dirty="0"/>
+              <a:t> zie je veel @for @if </a:t>
+            </a:r>
+            <a:r>
+              <a:rPr lang="nl-NL" dirty="0" err="1"/>
+              <a:t>etc</a:t>
+            </a:r>
+            <a:endParaRPr lang="nl-NL" dirty="0"/>
+          </a:p>
+          <a:p>
+            <a:endParaRPr lang="nl-NL" dirty="0"/>
+          </a:p>
+          <a:p>
+            <a:r>
+              <a:rPr lang="nl-NL" dirty="0"/>
+              <a:t>Dit wordt gewoon een &lt;?</a:t>
+            </a:r>
+            <a:r>
+              <a:rPr lang="nl-NL" dirty="0" err="1"/>
+              <a:t>php</a:t>
+            </a:r>
+            <a:r>
+              <a:rPr lang="nl-NL" dirty="0"/>
+              <a:t> </a:t>
+            </a:r>
+            <a:r>
+              <a:rPr lang="nl-NL" dirty="0" err="1"/>
+              <a:t>for</a:t>
+            </a:r>
+            <a:r>
+              <a:rPr lang="nl-NL" dirty="0"/>
+              <a:t>….</a:t>
+            </a:r>
+          </a:p>
+          <a:p>
+            <a:endParaRPr lang="nl-NL" dirty="0"/>
+          </a:p>
+          <a:p>
+            <a:r>
+              <a:rPr lang="nl-NL" dirty="0"/>
+              <a:t>Maar is:</a:t>
+            </a:r>
+          </a:p>
+          <a:p>
+            <a:pPr lvl="1"/>
+            <a:r>
+              <a:rPr lang="nl-NL" dirty="0"/>
+              <a:t>snelle typen</a:t>
+            </a:r>
+          </a:p>
+          <a:p>
+            <a:pPr lvl="1"/>
+            <a:r>
+              <a:rPr lang="nl-NL" dirty="0"/>
+              <a:t>cleaner om te zien</a:t>
+            </a:r>
+          </a:p>
+          <a:p>
+            <a:endParaRPr lang="nl-NL" dirty="0"/>
+          </a:p>
+          <a:p>
+            <a:r>
+              <a:rPr lang="nl-NL" dirty="0"/>
+              <a:t>Syntax Sugar ^^</a:t>
+            </a:r>
+          </a:p>
+        </p:txBody>
+      </p:sp>
+    </p:spTree>
+    <p:extLst>
+      <p:ext uri="{BB962C8B-B14F-4D97-AF65-F5344CB8AC3E}">
+        <p14:creationId xmlns:p14="http://schemas.microsoft.com/office/powerpoint/2010/main" val="218540331"/>
+      </p:ext>
+    </p:extLst>
+  </p:cSld>
+  <p:clrMapOvr>
+    <a:masterClrMapping/>
+  </p:clrMapOvr>
+</p:sld>
+</file>
+
+<file path=ppt/slides/slide11.xml><?xml version="1.0" encoding="utf-8"?>
+<p:sld xmlns:a="http://schemas.openxmlformats.org/drawingml/2006/main" xmlns:r="http://schemas.openxmlformats.org/officeDocument/2006/relationships" xmlns:p="http://schemas.openxmlformats.org/presentationml/2006/main">
+  <p:cSld>
+    <p:spTree>
+      <p:nvGrpSpPr>
+        <p:cNvPr id="1" name="">
+          <a:extLst>
+            <a:ext uri="{FF2B5EF4-FFF2-40B4-BE49-F238E27FC236}">
               <a16:creationId xmlns:a16="http://schemas.microsoft.com/office/drawing/2014/main" id="{4232822C-E8FA-9692-E1A0-E0A665EA73A2}"/>
             </a:ext>
           </a:extLst>
@@ -4003,7 +4192,7 @@
 </p:sld>
 </file>
 
-<file path=ppt/slides/slide11.xml><?xml version="1.0" encoding="utf-8"?>
+<file path=ppt/slides/slide12.xml><?xml version="1.0" encoding="utf-8"?>
 <p:sld xmlns:a="http://schemas.openxmlformats.org/drawingml/2006/main" xmlns:r="http://schemas.openxmlformats.org/officeDocument/2006/relationships" xmlns:p="http://schemas.openxmlformats.org/presentationml/2006/main">
   <p:cSld>
     <p:spTree>
@@ -4132,7 +4321,7 @@
 </p:sld>
 </file>
 
-<file path=ppt/slides/slide12.xml><?xml version="1.0" encoding="utf-8"?>
+<file path=ppt/slides/slide13.xml><?xml version="1.0" encoding="utf-8"?>
 <p:sld xmlns:a="http://schemas.openxmlformats.org/drawingml/2006/main" xmlns:r="http://schemas.openxmlformats.org/officeDocument/2006/relationships" xmlns:p="http://schemas.openxmlformats.org/presentationml/2006/main">
   <p:cSld>
     <p:spTree>
@@ -4316,7 +4505,7 @@
 </p:sld>
 </file>
 
-<file path=ppt/slides/slide13.xml><?xml version="1.0" encoding="utf-8"?>
+<file path=ppt/slides/slide14.xml><?xml version="1.0" encoding="utf-8"?>
 <p:sld xmlns:a="http://schemas.openxmlformats.org/drawingml/2006/main" xmlns:r="http://schemas.openxmlformats.org/officeDocument/2006/relationships" xmlns:p="http://schemas.openxmlformats.org/presentationml/2006/main">
   <p:cSld>
     <p:spTree>
@@ -4522,7 +4711,7 @@
 </p:sld>
 </file>
 
-<file path=ppt/slides/slide14.xml><?xml version="1.0" encoding="utf-8"?>
+<file path=ppt/slides/slide15.xml><?xml version="1.0" encoding="utf-8"?>
 <p:sld xmlns:a="http://schemas.openxmlformats.org/drawingml/2006/main" xmlns:r="http://schemas.openxmlformats.org/officeDocument/2006/relationships" xmlns:p="http://schemas.openxmlformats.org/presentationml/2006/main">
   <p:cSld>
     <p:spTree>
@@ -5118,6 +5307,17 @@
             </a:r>
             <a:endParaRPr lang="nl-NL" dirty="0"/>
           </a:p>
+          <a:p>
+            <a:pPr lvl="1"/>
+            <a:endParaRPr lang="nl-NL" dirty="0"/>
+          </a:p>
+          <a:p>
+            <a:pPr lvl="1"/>
+            <a:r>
+              <a:rPr lang="nl-NL" dirty="0"/>
+              <a:t>LET OP</a:t>
+            </a:r>
+          </a:p>
         </p:txBody>
       </p:sp>
       <p:pic>
@@ -5171,6 +5371,153 @@
         <p:cNvPr id="1" name="">
           <a:extLst>
             <a:ext uri="{FF2B5EF4-FFF2-40B4-BE49-F238E27FC236}">
+              <a16:creationId xmlns:a16="http://schemas.microsoft.com/office/drawing/2014/main" id="{9CAB7802-95C4-B611-3F8A-84C9EC65BC7D}"/>
+            </a:ext>
+          </a:extLst>
+        </p:cNvPr>
+        <p:cNvGrpSpPr/>
+        <p:nvPr/>
+      </p:nvGrpSpPr>
+      <p:grpSpPr>
+        <a:xfrm>
+          <a:off x="0" y="0"/>
+          <a:ext cx="0" cy="0"/>
+          <a:chOff x="0" y="0"/>
+          <a:chExt cx="0" cy="0"/>
+        </a:xfrm>
+      </p:grpSpPr>
+      <p:sp>
+        <p:nvSpPr>
+          <p:cNvPr id="2" name="Title 1">
+            <a:extLst>
+              <a:ext uri="{FF2B5EF4-FFF2-40B4-BE49-F238E27FC236}">
+                <a16:creationId xmlns:a16="http://schemas.microsoft.com/office/drawing/2014/main" id="{40A7B55D-529C-13A7-E740-2FAB3FEE61DC}"/>
+              </a:ext>
+            </a:extLst>
+          </p:cNvPr>
+          <p:cNvSpPr>
+            <a:spLocks noGrp="1"/>
+          </p:cNvSpPr>
+          <p:nvPr>
+            <p:ph type="title"/>
+          </p:nvPr>
+        </p:nvSpPr>
+        <p:spPr/>
+        <p:txBody>
+          <a:bodyPr/>
+          <a:lstStyle/>
+          <a:p>
+            <a:r>
+              <a:rPr lang="nl-NL" dirty="0"/>
+              <a:t>Composer </a:t>
+            </a:r>
+            <a:r>
+              <a:rPr lang="nl-NL" dirty="0" err="1"/>
+              <a:t>install</a:t>
+            </a:r>
+            <a:r>
+              <a:rPr lang="nl-NL" dirty="0"/>
+              <a:t> GOTCHA</a:t>
+            </a:r>
+          </a:p>
+        </p:txBody>
+      </p:sp>
+      <p:sp>
+        <p:nvSpPr>
+          <p:cNvPr id="3" name="Content Placeholder 2">
+            <a:extLst>
+              <a:ext uri="{FF2B5EF4-FFF2-40B4-BE49-F238E27FC236}">
+                <a16:creationId xmlns:a16="http://schemas.microsoft.com/office/drawing/2014/main" id="{D05685E2-71C0-EBAF-231E-B159B81562D5}"/>
+              </a:ext>
+            </a:extLst>
+          </p:cNvPr>
+          <p:cNvSpPr>
+            <a:spLocks noGrp="1"/>
+          </p:cNvSpPr>
+          <p:nvPr>
+            <p:ph idx="1"/>
+          </p:nvPr>
+        </p:nvSpPr>
+        <p:spPr>
+          <a:xfrm>
+            <a:off x="838200" y="1825625"/>
+            <a:ext cx="10741182" cy="4351338"/>
+          </a:xfrm>
+        </p:spPr>
+        <p:txBody>
+          <a:bodyPr/>
+          <a:lstStyle/>
+          <a:p>
+            <a:pPr lvl="1"/>
+            <a:r>
+              <a:rPr lang="nl-NL" dirty="0"/>
+              <a:t>LET OP:</a:t>
+            </a:r>
+          </a:p>
+          <a:p>
+            <a:pPr lvl="2"/>
+            <a:r>
+              <a:rPr lang="nl-NL" dirty="0"/>
+              <a:t>Als de composer </a:t>
+            </a:r>
+            <a:r>
+              <a:rPr lang="nl-NL" dirty="0" err="1"/>
+              <a:t>installer</a:t>
+            </a:r>
+            <a:r>
+              <a:rPr lang="nl-NL" dirty="0"/>
+              <a:t> niet werkt (SSL error/download </a:t>
+            </a:r>
+            <a:r>
+              <a:rPr lang="nl-NL" dirty="0" err="1"/>
+              <a:t>erro</a:t>
+            </a:r>
+            <a:r>
+              <a:rPr lang="nl-NL" dirty="0"/>
+              <a:t>)</a:t>
+            </a:r>
+          </a:p>
+          <a:p>
+            <a:pPr lvl="2"/>
+            <a:r>
+              <a:rPr lang="nl-NL" dirty="0"/>
+              <a:t>Zet even je virus scanner/web beveiliging uit</a:t>
+            </a:r>
+          </a:p>
+          <a:p>
+            <a:pPr lvl="2"/>
+            <a:r>
+              <a:rPr lang="nl-NL" dirty="0" err="1"/>
+              <a:t>Avast</a:t>
+            </a:r>
+            <a:r>
+              <a:rPr lang="nl-NL" dirty="0"/>
+              <a:t> bijvoorbeeld</a:t>
+            </a:r>
+          </a:p>
+        </p:txBody>
+      </p:sp>
+    </p:spTree>
+    <p:extLst>
+      <p:ext uri="{BB962C8B-B14F-4D97-AF65-F5344CB8AC3E}">
+        <p14:creationId xmlns:p14="http://schemas.microsoft.com/office/powerpoint/2010/main" val="3784629920"/>
+      </p:ext>
+    </p:extLst>
+  </p:cSld>
+  <p:clrMapOvr>
+    <a:masterClrMapping/>
+  </p:clrMapOvr>
+</p:sld>
+</file>
+
+<file path=ppt/slides/slide6.xml><?xml version="1.0" encoding="utf-8"?>
+<p:sld xmlns:a="http://schemas.openxmlformats.org/drawingml/2006/main" xmlns:r="http://schemas.openxmlformats.org/officeDocument/2006/relationships" xmlns:p="http://schemas.openxmlformats.org/presentationml/2006/main">
+  <p:cSld>
+    <p:spTree>
+      <p:nvGrpSpPr>
+        <p:cNvPr id="1" name="">
+          <a:extLst>
+            <a:ext uri="{FF2B5EF4-FFF2-40B4-BE49-F238E27FC236}">
               <a16:creationId xmlns:a16="http://schemas.microsoft.com/office/drawing/2014/main" id="{5A40C60C-5416-6983-D1D5-70D700928BA6}"/>
             </a:ext>
           </a:extLst>
@@ -5290,7 +5637,7 @@
 </p:sld>
 </file>
 
-<file path=ppt/slides/slide6.xml><?xml version="1.0" encoding="utf-8"?>
+<file path=ppt/slides/slide7.xml><?xml version="1.0" encoding="utf-8"?>
 <p:sld xmlns:a="http://schemas.openxmlformats.org/drawingml/2006/main" xmlns:r="http://schemas.openxmlformats.org/officeDocument/2006/relationships" xmlns:p="http://schemas.openxmlformats.org/presentationml/2006/main">
   <p:cSld>
     <p:spTree>
@@ -5506,7 +5853,7 @@
 </p:sld>
 </file>
 
-<file path=ppt/slides/slide7.xml><?xml version="1.0" encoding="utf-8"?>
+<file path=ppt/slides/slide8.xml><?xml version="1.0" encoding="utf-8"?>
 <p:sld xmlns:a="http://schemas.openxmlformats.org/drawingml/2006/main" xmlns:r="http://schemas.openxmlformats.org/officeDocument/2006/relationships" xmlns:p="http://schemas.openxmlformats.org/presentationml/2006/main">
   <p:cSld>
     <p:spTree>
@@ -5688,7 +6035,7 @@
 </p:sld>
 </file>
 
-<file path=ppt/slides/slide8.xml><?xml version="1.0" encoding="utf-8"?>
+<file path=ppt/slides/slide9.xml><?xml version="1.0" encoding="utf-8"?>
 <p:sld xmlns:a="http://schemas.openxmlformats.org/drawingml/2006/main" xmlns:r="http://schemas.openxmlformats.org/officeDocument/2006/relationships" xmlns:p="http://schemas.openxmlformats.org/presentationml/2006/main">
   <p:cSld>
     <p:spTree>
@@ -5745,170 +6092,6 @@
     <p:extLst>
       <p:ext uri="{BB962C8B-B14F-4D97-AF65-F5344CB8AC3E}">
         <p14:creationId xmlns:p14="http://schemas.microsoft.com/office/powerpoint/2010/main" val="780809917"/>
-      </p:ext>
-    </p:extLst>
-  </p:cSld>
-  <p:clrMapOvr>
-    <a:masterClrMapping/>
-  </p:clrMapOvr>
-</p:sld>
-</file>
-
-<file path=ppt/slides/slide9.xml><?xml version="1.0" encoding="utf-8"?>
-<p:sld xmlns:a="http://schemas.openxmlformats.org/drawingml/2006/main" xmlns:r="http://schemas.openxmlformats.org/officeDocument/2006/relationships" xmlns:p="http://schemas.openxmlformats.org/presentationml/2006/main">
-  <p:cSld>
-    <p:spTree>
-      <p:nvGrpSpPr>
-        <p:cNvPr id="1" name="">
-          <a:extLst>
-            <a:ext uri="{FF2B5EF4-FFF2-40B4-BE49-F238E27FC236}">
-              <a16:creationId xmlns:a16="http://schemas.microsoft.com/office/drawing/2014/main" id="{2EAACB33-43BE-EDF1-1A9E-034E28C6C768}"/>
-            </a:ext>
-          </a:extLst>
-        </p:cNvPr>
-        <p:cNvGrpSpPr/>
-        <p:nvPr/>
-      </p:nvGrpSpPr>
-      <p:grpSpPr>
-        <a:xfrm>
-          <a:off x="0" y="0"/>
-          <a:ext cx="0" cy="0"/>
-          <a:chOff x="0" y="0"/>
-          <a:chExt cx="0" cy="0"/>
-        </a:xfrm>
-      </p:grpSpPr>
-      <p:sp>
-        <p:nvSpPr>
-          <p:cNvPr id="2" name="Title 1">
-            <a:extLst>
-              <a:ext uri="{FF2B5EF4-FFF2-40B4-BE49-F238E27FC236}">
-                <a16:creationId xmlns:a16="http://schemas.microsoft.com/office/drawing/2014/main" id="{79ACB165-A2D9-F103-EA6F-93584CC5166C}"/>
-              </a:ext>
-            </a:extLst>
-          </p:cNvPr>
-          <p:cNvSpPr>
-            <a:spLocks noGrp="1"/>
-          </p:cNvSpPr>
-          <p:nvPr>
-            <p:ph type="title"/>
-          </p:nvPr>
-        </p:nvSpPr>
-        <p:spPr/>
-        <p:txBody>
-          <a:bodyPr/>
-          <a:lstStyle/>
-          <a:p>
-            <a:r>
-              <a:rPr lang="nl-NL" dirty="0"/>
-              <a:t>@@@@@@</a:t>
-            </a:r>
-          </a:p>
-        </p:txBody>
-      </p:sp>
-      <p:sp>
-        <p:nvSpPr>
-          <p:cNvPr id="3" name="Content Placeholder 2">
-            <a:extLst>
-              <a:ext uri="{FF2B5EF4-FFF2-40B4-BE49-F238E27FC236}">
-                <a16:creationId xmlns:a16="http://schemas.microsoft.com/office/drawing/2014/main" id="{18E7F1CB-60BD-BCA2-61ED-D714D805A39C}"/>
-              </a:ext>
-            </a:extLst>
-          </p:cNvPr>
-          <p:cNvSpPr>
-            <a:spLocks noGrp="1"/>
-          </p:cNvSpPr>
-          <p:nvPr>
-            <p:ph idx="1"/>
-          </p:nvPr>
-        </p:nvSpPr>
-        <p:spPr/>
-        <p:txBody>
-          <a:bodyPr>
-            <a:normAutofit/>
-          </a:bodyPr>
-          <a:lstStyle/>
-          <a:p>
-            <a:r>
-              <a:rPr lang="nl-NL" dirty="0"/>
-              <a:t>In de </a:t>
-            </a:r>
-            <a:r>
-              <a:rPr lang="nl-NL" dirty="0" err="1"/>
-              <a:t>blade</a:t>
-            </a:r>
-            <a:r>
-              <a:rPr lang="nl-NL" dirty="0"/>
-              <a:t> zie je veel @for @if </a:t>
-            </a:r>
-            <a:r>
-              <a:rPr lang="nl-NL" dirty="0" err="1"/>
-              <a:t>etc</a:t>
-            </a:r>
-            <a:endParaRPr lang="nl-NL" dirty="0"/>
-          </a:p>
-          <a:p>
-            <a:endParaRPr lang="nl-NL" dirty="0"/>
-          </a:p>
-          <a:p>
-            <a:r>
-              <a:rPr lang="nl-NL" dirty="0"/>
-              <a:t>Dit wordt gewoon een &lt;?</a:t>
-            </a:r>
-            <a:r>
-              <a:rPr lang="nl-NL" dirty="0" err="1"/>
-              <a:t>php</a:t>
-            </a:r>
-            <a:r>
-              <a:rPr lang="nl-NL" dirty="0"/>
-              <a:t> </a:t>
-            </a:r>
-            <a:r>
-              <a:rPr lang="nl-NL" dirty="0" err="1"/>
-              <a:t>for</a:t>
-            </a:r>
-            <a:r>
-              <a:rPr lang="nl-NL" dirty="0"/>
-              <a:t>….</a:t>
-            </a:r>
-          </a:p>
-          <a:p>
-            <a:endParaRPr lang="nl-NL" dirty="0"/>
-          </a:p>
-          <a:p>
-            <a:r>
-              <a:rPr lang="nl-NL" dirty="0"/>
-              <a:t>Maar is:</a:t>
-            </a:r>
-          </a:p>
-          <a:p>
-            <a:pPr lvl="1"/>
-            <a:r>
-              <a:rPr lang="nl-NL" dirty="0"/>
-              <a:t>snelle typen</a:t>
-            </a:r>
-          </a:p>
-          <a:p>
-            <a:pPr lvl="1"/>
-            <a:r>
-              <a:rPr lang="nl-NL" dirty="0"/>
-              <a:t>cleaner om te zien</a:t>
-            </a:r>
-          </a:p>
-          <a:p>
-            <a:endParaRPr lang="nl-NL" dirty="0"/>
-          </a:p>
-          <a:p>
-            <a:r>
-              <a:rPr lang="nl-NL" dirty="0"/>
-              <a:t>Syntax Sugar ^^</a:t>
-            </a:r>
-          </a:p>
-        </p:txBody>
-      </p:sp>
-    </p:spTree>
-    <p:extLst>
-      <p:ext uri="{BB962C8B-B14F-4D97-AF65-F5344CB8AC3E}">
-        <p14:creationId xmlns:p14="http://schemas.microsoft.com/office/powerpoint/2010/main" val="218540331"/>
       </p:ext>
     </p:extLst>
   </p:cSld>

</xml_diff>